<commit_message>
docs(showcase): update hackathon partners and Aklan venue
</commit_message>
<xml_diff>
--- a/docs/showcase/paiflow-showcase-webinar-design.pptx
+++ b/docs/showcase/paiflow-showcase-webinar-design.pptx
@@ -858,7 +858,7 @@
           <a:p>
             <a:r>
               <a:rPr lang="en-US" dirty="0"/>
-              <a:t>4:15–4:40. Say: We’re planning two hackathons in collaboration with JRU and Web3 Iloilo, followed by weekly builder sessions. We’ll also bring a hands-on Paiflow booth to BlockQuest Fiesta PH in Laguna. In Aklan, we plan to join a university event to bring Paiflow to more students through a booth, a mini hackathon, or both. That event is in planning, with its date to be confirmed. 4:40–4:50 close: Draw the flow, sign it, and watch the payment land. Try Paiflow at paiflow.xyz and inspect the receipts in our docs. Thank you. 4:50–5:00 buffer. Two hackathons and collaborators confirmed by the user; this supersedes the PDF’s single university hackathon. No team-count total is assumed for the two events. Aklan framing follows the October 3 forecast PDF: joining a university event, booth/mini hackathon/both, in planning, date TBC. Planned events, not completed results.</a:t>
+              <a:t>4:15–4:40. Say: We’re planning three hackathons in collaboration with JRU, Web3 Iloilo, and FEU Tech, followed by weekly builder sessions. We’ll also bring a hands-on Paiflow booth to BlockQuest Fiesta PH in Laguna. In Aklan, we plan to join an event at Northwestern Visayan College to bring Paiflow to more students through a booth, a mini hackathon, or both. 4:40–4:50 close: Draw the flow, sign it, and watch the payment land. Try Paiflow at paiflow.xyz and inspect the receipts in our docs. Thank you. 4:50–5:00 buffer. Three hackathons and collaborators confirmed by the user, including FEU Tech. No combined team capacity is assumed. The user identified Northwestern Visayan College for Aklan and requested removal of the planning/date label. The booth, mini hackathon, or both framing remains. Planned events, not completed results.</a:t>
             </a:r>
             <a:endParaRPr lang="en-US" dirty="0"/>
           </a:p>
@@ -4919,7 +4919,7 @@
                 <a:ea typeface="JetBrains Mono" pitchFamily="34" charset="-122"/>
                 <a:cs typeface="JetBrains Mono" pitchFamily="34" charset="-120"/>
               </a:rPr>
-              <a:t>2 hackathons</a:t>
+              <a:t>3 hackathons</a:t>
             </a:r>
             <a:endParaRPr lang="en-US" sz="3500" dirty="0"/>
           </a:p>
@@ -4950,7 +4950,7 @@
               <a:buNone/>
             </a:pPr>
             <a:r>
-              <a:rPr lang="en-US" sz="2200" dirty="0">
+              <a:rPr lang="en-US" sz="2000" dirty="0">
                 <a:solidFill>
                   <a:srgbClr val="E5E2E1"/>
                 </a:solidFill>
@@ -4960,14 +4960,14 @@
               </a:rPr>
               <a:t>In collaboration with</a:t>
             </a:r>
-            <a:endParaRPr lang="en-US" sz="2200" dirty="0"/>
-          </a:p>
-          <a:p>
-            <a:pPr indent="0" marL="0">
-              <a:buNone/>
-            </a:pPr>
-            <a:r>
-              <a:rPr lang="en-US" sz="2200" dirty="0">
+            <a:endParaRPr lang="en-US" sz="2000" dirty="0"/>
+          </a:p>
+          <a:p>
+            <a:pPr indent="0" marL="0">
+              <a:buNone/>
+            </a:pPr>
+            <a:r>
+              <a:rPr lang="en-US" sz="2000" dirty="0">
                 <a:solidFill>
                   <a:srgbClr val="E5E2E1"/>
                 </a:solidFill>
@@ -4975,9 +4975,9 @@
                 <a:ea typeface="Inter" pitchFamily="34" charset="-122"/>
                 <a:cs typeface="Inter" pitchFamily="34" charset="-120"/>
               </a:rPr>
-              <a:t>JRU + Web3 Iloilo.</a:t>
-            </a:r>
-            <a:endParaRPr lang="en-US" sz="2200" dirty="0"/>
+              <a:t>JRU + Web3 Iloilo + FEU Tech.</a:t>
+            </a:r>
+            <a:endParaRPr lang="en-US" sz="2000" dirty="0"/>
           </a:p>
         </p:txBody>
       </p:sp>
@@ -5232,7 +5232,7 @@
                 <a:ea typeface="JetBrains Mono" pitchFamily="34" charset="-122"/>
                 <a:cs typeface="JetBrains Mono" pitchFamily="34" charset="-120"/>
               </a:rPr>
-              <a:t>AKLAN · IN PLANNING · DATE TBC</a:t>
+              <a:t>AKLAN · NORTHWESTERN VISAYAN COLLEGE</a:t>
             </a:r>
             <a:endParaRPr lang="en-US" sz="1050" dirty="0"/>
           </a:p>

</xml_diff>

<commit_message>
docs: update showcase closing and consolidate alpha feedback
</commit_message>
<xml_diff>
--- a/docs/showcase/paiflow-showcase-webinar-design.pptx
+++ b/docs/showcase/paiflow-showcase-webinar-design.pptx
@@ -10,9 +10,10 @@
     <p:sldId id="258" r:id="rId4"/>
     <p:sldId id="259" r:id="rId5"/>
     <p:sldId id="260" r:id="rId6"/>
+    <p:sldId id="261" r:id="rId7"/>
   </p:sldIdLst>
   <p:notesMasterIdLst>
-    <p:notesMasterId r:id="rId7"/>
+    <p:notesMasterId r:id="rId8"/>
   </p:notesMasterIdLst>
   <p:sldSz cx="12192000" cy="6858000"/>
   <p:notesSz cx="6858000" cy="12192000"/>
@@ -858,7 +859,7 @@
           <a:p>
             <a:r>
               <a:rPr lang="en-US" dirty="0"/>
-              <a:t>4:15–4:40. Say: We’re planning three hackathons in collaboration with JRU, Web3 Iloilo, and FEU Tech, followed by weekly builder sessions. We’ll also bring a hands-on Paiflow booth to BlockQuest Fiesta PH in Laguna. In Aklan, we plan to join an event at Northwestern Visayan College to bring Paiflow to more students through a booth, a mini hackathon, or both. 4:40–4:50 close: Draw the flow, sign it, and watch the payment land. Try Paiflow at paiflow.xyz and inspect the receipts in our docs. Thank you. 4:50–5:00 buffer. Three hackathons and collaborators confirmed by the user, including FEU Tech. No combined team capacity is assumed. The user identified Northwestern Visayan College for Aklan and requested removal of the planning/date label. The booth, mini hackathon, or both framing remains. Planned events, not completed results.</a:t>
+              <a:t>4:15–4:40. Say: We’re planning three hackathons in collaboration with JRU, Web3 Iloilo, and FEU Tech, followed by weekly builder sessions. We’ll also bring a hands-on Paiflow booth to BlockQuest Fiesta PH in Laguna. In Aklan, we plan to join an event at Northwestern Visayan College to bring Paiflow to more students through a booth, a mini hackathon, or both. Then advance to the final social slide for the closing. Three hackathons and collaborators confirmed by the user, including FEU Tech. No combined team capacity is assumed. The user identified Northwestern Visayan College for Aklan and requested removal of the planning/date label. The booth, mini hackathon, or both framing remains. Planned events, not completed results.</a:t>
             </a:r>
             <a:endParaRPr lang="en-US" dirty="0"/>
           </a:p>
@@ -882,6 +883,94 @@
             <a:fld id="{F7021451-1387-4CA6-816F-3879F97B5CBC}" type="slidenum">
               <a:rPr lang="en-US"/>
               <a:t>5</a:t>
+            </a:fld>
+            <a:endParaRPr lang="en-US"/>
+          </a:p>
+        </p:txBody>
+      </p:sp>
+    </p:spTree>
+    <p:extLst>
+      <p:ext uri="{BB962C8B-B14F-4D97-AF65-F5344CB8AC3E}">
+        <p14:creationId xmlns:p14="http://schemas.microsoft.com/office/powerpoint/2010/main" val="1024086991"/>
+      </p:ext>
+    </p:extLst>
+  </p:cSld>
+  <p:clrMapOvr>
+    <a:masterClrMapping/>
+  </p:clrMapOvr>
+</p:notes>
+</file>
+
+<file path=ppt/notesSlides/notesSlide6.xml><?xml version="1.0" encoding="utf-8"?>
+<p:notes xmlns:a="http://schemas.openxmlformats.org/drawingml/2006/main" xmlns:r="http://schemas.openxmlformats.org/officeDocument/2006/relationships" xmlns:p="http://schemas.openxmlformats.org/presentationml/2006/main">
+  <p:cSld>
+    <p:spTree>
+      <p:nvGrpSpPr>
+        <p:cNvPr id="1" name=""/>
+        <p:cNvGrpSpPr/>
+        <p:nvPr/>
+      </p:nvGrpSpPr>
+      <p:grpSpPr>
+        <a:xfrm>
+          <a:off x="0" y="0"/>
+          <a:ext cx="0" cy="0"/>
+          <a:chOff x="0" y="0"/>
+          <a:chExt cx="0" cy="0"/>
+        </a:xfrm>
+      </p:grpSpPr>
+      <p:sp>
+        <p:nvSpPr>
+          <p:cNvPr id="2" name="Slide Image Placeholder 1"/>
+          <p:cNvSpPr>
+            <a:spLocks noGrp="1" noRot="1" noChangeAspect="1"/>
+          </p:cNvSpPr>
+          <p:nvPr>
+            <p:ph type="sldImg"/>
+          </p:nvPr>
+        </p:nvSpPr>
+        <p:spPr/>
+      </p:sp>
+      <p:sp>
+        <p:nvSpPr>
+          <p:cNvPr id="3" name="Notes Placeholder 2"/>
+          <p:cNvSpPr>
+            <a:spLocks noGrp="1"/>
+          </p:cNvSpPr>
+          <p:nvPr>
+            <p:ph type="body" idx="1"/>
+          </p:nvPr>
+        </p:nvSpPr>
+        <p:spPr/>
+        <p:txBody>
+          <a:bodyPr/>
+          <a:lstStyle/>
+          <a:p>
+            <a:r>
+              <a:rPr lang="en-US" dirty="0"/>
+              <a:t>4:40–4:50. Close: Draw the flow, sign it, and watch the payment land. Try Paiflow at paiflow.xyz, follow @usepaiflow on X using the QR code, and inspect the receipts in our docs. Thank you. Leave this slide visible so viewers can scan the code. 4:50–5:00 buffer.</a:t>
+            </a:r>
+            <a:endParaRPr lang="en-US" dirty="0"/>
+          </a:p>
+        </p:txBody>
+      </p:sp>
+      <p:sp>
+        <p:nvSpPr>
+          <p:cNvPr id="4" name="Slide Number Placeholder 3"/>
+          <p:cNvSpPr>
+            <a:spLocks noGrp="1"/>
+          </p:cNvSpPr>
+          <p:nvPr>
+            <p:ph type="sldNum" sz="quarter" idx="10"/>
+          </p:nvPr>
+        </p:nvSpPr>
+        <p:spPr/>
+        <p:txBody>
+          <a:bodyPr/>
+          <a:lstStyle/>
+          <a:p>
+            <a:fld id="{F7021451-1387-4CA6-816F-3879F97B5CBC}" type="slidenum">
+              <a:rPr lang="en-US"/>
+              <a:t>6</a:t>
             </a:fld>
             <a:endParaRPr lang="en-US"/>
           </a:p>
@@ -2036,7 +2125,7 @@
                 <a:ea typeface="JetBrains Mono" pitchFamily="34" charset="-122"/>
                 <a:cs typeface="JetBrains Mono" pitchFamily="34" charset="-120"/>
               </a:rPr>
-              <a:t>02 / 5</a:t>
+              <a:t>02 / 6</a:t>
             </a:r>
             <a:endParaRPr lang="en-US" sz="900" dirty="0"/>
           </a:p>
@@ -2784,7 +2873,7 @@
                 <a:ea typeface="JetBrains Mono" pitchFamily="34" charset="-122"/>
                 <a:cs typeface="JetBrains Mono" pitchFamily="34" charset="-120"/>
               </a:rPr>
-              <a:t>03 / 5</a:t>
+              <a:t>03 / 6</a:t>
             </a:r>
             <a:endParaRPr lang="en-US" sz="900" dirty="0"/>
           </a:p>
@@ -3354,7 +3443,7 @@
                 <a:ea typeface="JetBrains Mono" pitchFamily="34" charset="-122"/>
                 <a:cs typeface="JetBrains Mono" pitchFamily="34" charset="-120"/>
               </a:rPr>
-              <a:t>04 / 5</a:t>
+              <a:t>04 / 6</a:t>
             </a:r>
             <a:endParaRPr lang="en-US" sz="900" dirty="0"/>
           </a:p>
@@ -4810,7 +4899,7 @@
                 <a:ea typeface="JetBrains Mono" pitchFamily="34" charset="-122"/>
                 <a:cs typeface="JetBrains Mono" pitchFamily="34" charset="-120"/>
               </a:rPr>
-              <a:t>05 / 5</a:t>
+              <a:t>05 / 6</a:t>
             </a:r>
             <a:endParaRPr lang="en-US" sz="900" dirty="0"/>
           </a:p>
@@ -5369,6 +5458,314 @@
               <a:t>paiflow.xyz</a:t>
             </a:r>
             <a:endParaRPr lang="en-US" sz="1000" dirty="0"/>
+          </a:p>
+        </p:txBody>
+      </p:sp>
+    </p:spTree>
+  </p:cSld>
+  <p:clrMapOvr>
+    <a:masterClrMapping/>
+  </p:clrMapOvr>
+</p:sld>
+</file>
+
+<file path=ppt/slides/slide6.xml><?xml version="1.0" encoding="utf-8"?>
+<p:sld xmlns:a="http://schemas.openxmlformats.org/drawingml/2006/main" xmlns:r="http://schemas.openxmlformats.org/officeDocument/2006/relationships" xmlns:p="http://schemas.openxmlformats.org/presentationml/2006/main">
+  <p:cSld name="Slide 6">
+    <p:bg>
+      <p:bgPr>
+        <a:blipFill dpi="0" rotWithShape="1">
+          <a:blip r:embed="rId1">
+            <a:lum/>
+          </a:blip>
+          <a:srcRect/>
+          <a:stretch>
+            <a:fillRect/>
+          </a:stretch>
+        </a:blipFill>
+        <a:effectLst/>
+      </p:bgPr>
+    </p:bg>
+    <p:spTree>
+      <p:nvGrpSpPr>
+        <p:cNvPr id="1" name=""/>
+        <p:cNvGrpSpPr/>
+        <p:nvPr/>
+      </p:nvGrpSpPr>
+      <p:grpSpPr>
+        <a:xfrm>
+          <a:off x="0" y="0"/>
+          <a:ext cx="0" cy="0"/>
+          <a:chOff x="0" y="0"/>
+          <a:chExt cx="0" cy="0"/>
+        </a:xfrm>
+      </p:grpSpPr>
+      <p:sp>
+        <p:nvSpPr>
+          <p:cNvPr id="2" name="Text 0"/>
+          <p:cNvSpPr txBox="1"/>
+          <p:nvPr/>
+        </p:nvSpPr>
+        <p:spPr>
+          <a:xfrm>
+            <a:off x="640080" y="502920"/>
+            <a:ext cx="8229600" cy="274320"/>
+          </a:xfrm>
+          <a:prstGeom prst="rect">
+            <a:avLst/>
+          </a:prstGeom>
+          <a:noFill/>
+          <a:ln/>
+        </p:spPr>
+        <p:txBody>
+          <a:bodyPr wrap="square" lIns="0" tIns="0" rIns="0" bIns="0" rtlCol="0" anchor="ctr"/>
+          <a:lstStyle/>
+          <a:p>
+            <a:pPr indent="0" marL="0">
+              <a:buNone/>
+            </a:pPr>
+            <a:r>
+              <a:rPr lang="en-US" sz="1100" b="1" spc="150" kern="0" dirty="0">
+                <a:solidFill>
+                  <a:srgbClr val="FFB1C4"/>
+                </a:solidFill>
+                <a:latin typeface="JetBrains Mono" pitchFamily="34" charset="0"/>
+                <a:ea typeface="JetBrains Mono" pitchFamily="34" charset="-122"/>
+                <a:cs typeface="JetBrains Mono" pitchFamily="34" charset="-120"/>
+              </a:rPr>
+              <a:t>STAY CONNECTED</a:t>
+            </a:r>
+            <a:endParaRPr lang="en-US" sz="1100" dirty="0"/>
+          </a:p>
+        </p:txBody>
+      </p:sp>
+      <p:sp>
+        <p:nvSpPr>
+          <p:cNvPr id="3" name="Text 1"/>
+          <p:cNvSpPr txBox="1"/>
+          <p:nvPr/>
+        </p:nvSpPr>
+        <p:spPr>
+          <a:xfrm>
+            <a:off x="640080" y="804672"/>
+            <a:ext cx="9692640" cy="777240"/>
+          </a:xfrm>
+          <a:prstGeom prst="rect">
+            <a:avLst/>
+          </a:prstGeom>
+          <a:noFill/>
+          <a:ln/>
+        </p:spPr>
+        <p:txBody>
+          <a:bodyPr wrap="square" lIns="0" tIns="0" rIns="0" bIns="0" rtlCol="0" anchor="ctr"/>
+          <a:lstStyle/>
+          <a:p>
+            <a:pPr indent="0" marL="0">
+              <a:buNone/>
+            </a:pPr>
+            <a:r>
+              <a:rPr lang="en-US" sz="4000" b="1" spc="-50" kern="0" dirty="0">
+                <a:solidFill>
+                  <a:srgbClr val="E5E2E1"/>
+                </a:solidFill>
+                <a:latin typeface="Inter" pitchFamily="34" charset="0"/>
+                <a:ea typeface="Inter" pitchFamily="34" charset="-122"/>
+                <a:cs typeface="Inter" pitchFamily="34" charset="-120"/>
+              </a:rPr>
+              <a:t>Follow Paiflow on X.</a:t>
+            </a:r>
+            <a:endParaRPr lang="en-US" sz="4000" dirty="0"/>
+          </a:p>
+        </p:txBody>
+      </p:sp>
+      <p:sp>
+        <p:nvSpPr>
+          <p:cNvPr id="4" name="Text 2"/>
+          <p:cNvSpPr txBox="1"/>
+          <p:nvPr/>
+        </p:nvSpPr>
+        <p:spPr>
+          <a:xfrm>
+            <a:off x="640080" y="6400800"/>
+            <a:ext cx="4572000" cy="228600"/>
+          </a:xfrm>
+          <a:prstGeom prst="rect">
+            <a:avLst/>
+          </a:prstGeom>
+          <a:noFill/>
+          <a:ln/>
+        </p:spPr>
+        <p:txBody>
+          <a:bodyPr wrap="square" lIns="0" tIns="0" rIns="0" bIns="0" rtlCol="0" anchor="ctr"/>
+          <a:lstStyle/>
+          <a:p>
+            <a:pPr indent="0" marL="0">
+              <a:buNone/>
+            </a:pPr>
+            <a:r>
+              <a:rPr lang="en-US" sz="900" dirty="0">
+                <a:solidFill>
+                  <a:srgbClr val="BCB8BB"/>
+                </a:solidFill>
+                <a:latin typeface="JetBrains Mono" pitchFamily="34" charset="0"/>
+                <a:ea typeface="JetBrains Mono" pitchFamily="34" charset="-122"/>
+                <a:cs typeface="JetBrains Mono" pitchFamily="34" charset="-120"/>
+              </a:rPr>
+              <a:t>Paiflow · InstaAwards Builder Showcase</a:t>
+            </a:r>
+            <a:endParaRPr lang="en-US" sz="900" dirty="0"/>
+          </a:p>
+        </p:txBody>
+      </p:sp>
+      <p:sp>
+        <p:nvSpPr>
+          <p:cNvPr id="5" name="Text 3"/>
+          <p:cNvSpPr txBox="1"/>
+          <p:nvPr/>
+        </p:nvSpPr>
+        <p:spPr>
+          <a:xfrm>
+            <a:off x="9722815" y="6400800"/>
+            <a:ext cx="1828800" cy="228600"/>
+          </a:xfrm>
+          <a:prstGeom prst="rect">
+            <a:avLst/>
+          </a:prstGeom>
+          <a:noFill/>
+          <a:ln/>
+        </p:spPr>
+        <p:txBody>
+          <a:bodyPr wrap="square" lIns="0" tIns="0" rIns="0" bIns="0" rtlCol="0" anchor="ctr"/>
+          <a:lstStyle/>
+          <a:p>
+            <a:pPr algn="r" indent="0" marL="0">
+              <a:buNone/>
+            </a:pPr>
+            <a:r>
+              <a:rPr lang="en-US" sz="900" dirty="0">
+                <a:solidFill>
+                  <a:srgbClr val="BCB8BB"/>
+                </a:solidFill>
+                <a:latin typeface="JetBrains Mono" pitchFamily="34" charset="0"/>
+                <a:ea typeface="JetBrains Mono" pitchFamily="34" charset="-122"/>
+                <a:cs typeface="JetBrains Mono" pitchFamily="34" charset="-120"/>
+              </a:rPr>
+              <a:t>06 / 6</a:t>
+            </a:r>
+            <a:endParaRPr lang="en-US" sz="900" dirty="0"/>
+          </a:p>
+        </p:txBody>
+      </p:sp>
+      <p:pic>
+        <p:nvPicPr>
+          <p:cNvPr id="7" name="Image 0" descr="/home/salt/Documents/VS_Code/artisam/pinkraft-2/pinkraft/docs/showcase/webinar-design/assets/x-usepaiflow-qr.png">
+            <a:hlinkClick r:id="rId3" tooltip=""/>
+          </p:cNvPr>
+          <p:cNvPicPr>
+            <a:picLocks noChangeAspect="1"/>
+          </p:cNvPicPr>
+          <p:nvPr/>
+        </p:nvPicPr>
+        <p:blipFill>
+          <a:blip r:embed="rId2"/>
+          <a:stretch>
+            <a:fillRect/>
+          </a:stretch>
+        </p:blipFill>
+        <p:spPr>
+          <a:xfrm>
+            <a:off x="4587088" y="1920240"/>
+            <a:ext cx="3017520" cy="3017520"/>
+          </a:xfrm>
+          <a:prstGeom prst="rect">
+            <a:avLst/>
+          </a:prstGeom>
+        </p:spPr>
+      </p:pic>
+      <p:sp>
+        <p:nvSpPr>
+          <p:cNvPr id="8" name="Text 4">
+            <a:hlinkClick r:id="rId4" tooltip=""/>
+          </p:cNvPr>
+          <p:cNvSpPr txBox="1"/>
+          <p:nvPr/>
+        </p:nvSpPr>
+        <p:spPr>
+          <a:xfrm>
+            <a:off x="640080" y="5212080"/>
+            <a:ext cx="10911535" cy="548640"/>
+          </a:xfrm>
+          <a:prstGeom prst="rect">
+            <a:avLst/>
+          </a:prstGeom>
+          <a:noFill/>
+          <a:ln/>
+        </p:spPr>
+        <p:txBody>
+          <a:bodyPr wrap="square" lIns="0" tIns="0" rIns="0" bIns="0" rtlCol="0" anchor="t"/>
+          <a:lstStyle/>
+          <a:p>
+            <a:pPr algn="ctr" indent="0" marL="0">
+              <a:buNone/>
+            </a:pPr>
+            <a:r>
+              <a:rPr lang="en-US" sz="3200" b="1" u="sng" dirty="0">
+                <a:solidFill>
+                  <a:srgbClr val="FFB1C4"/>
+                </a:solidFill>
+                <a:latin typeface="Inter" pitchFamily="34" charset="0"/>
+                <a:ea typeface="Inter" pitchFamily="34" charset="-122"/>
+                <a:cs typeface="Inter" pitchFamily="34" charset="-120"/>
+                <a:hlinkClick r:id="rId4" invalidUrl="" action="" tgtFrame="" tooltip="" history="1" highlightClick="0" endSnd="0">
+                  <a:extLst>
+                    <a:ext uri="{A12FA001-AC4F-418D-AE19-62706E023703}">
+                      <ahyp:hlinkClr xmlns:ahyp="http://schemas.microsoft.com/office/drawing/2018/hyperlinkcolor" val="tx"/>
+                    </a:ext>
+                  </a:extLst>
+                </a:hlinkClick>
+              </a:rPr>
+              <a:t>@usepaiflow</a:t>
+            </a:r>
+            <a:endParaRPr lang="en-US" sz="3200" dirty="0"/>
+          </a:p>
+        </p:txBody>
+      </p:sp>
+      <p:sp>
+        <p:nvSpPr>
+          <p:cNvPr id="9" name="Text 5"/>
+          <p:cNvSpPr txBox="1"/>
+          <p:nvPr/>
+        </p:nvSpPr>
+        <p:spPr>
+          <a:xfrm>
+            <a:off x="640080" y="5870448"/>
+            <a:ext cx="10911535" cy="274320"/>
+          </a:xfrm>
+          <a:prstGeom prst="rect">
+            <a:avLst/>
+          </a:prstGeom>
+          <a:noFill/>
+          <a:ln/>
+        </p:spPr>
+        <p:txBody>
+          <a:bodyPr wrap="square" lIns="0" tIns="0" rIns="0" bIns="0" rtlCol="0" anchor="t"/>
+          <a:lstStyle/>
+          <a:p>
+            <a:pPr algn="ctr" indent="0" marL="0">
+              <a:buNone/>
+            </a:pPr>
+            <a:r>
+              <a:rPr lang="en-US" sz="1500" dirty="0">
+                <a:solidFill>
+                  <a:srgbClr val="BCB8BB"/>
+                </a:solidFill>
+                <a:latin typeface="Inter" pitchFamily="34" charset="0"/>
+                <a:ea typeface="Inter" pitchFamily="34" charset="-122"/>
+                <a:cs typeface="Inter" pitchFamily="34" charset="-120"/>
+              </a:rPr>
+              <a:t>Scan to follow</a:t>
+            </a:r>
+            <a:endParaRPr lang="en-US" sz="1500" dirty="0"/>
           </a:p>
         </p:txBody>
       </p:sp>

</xml_diff>